<commit_message>
Fix: Token optimization, removed polish & fixed doc duplicate title page
</commit_message>
<xml_diff>
--- a/logo/Sertifikat/Nomsiz taqdimot.pptx
+++ b/logo/Sertifikat/Nomsiz taqdimot.pptx
@@ -14,20 +14,22 @@
   <p:notesSz cx="6858000" cy="9144000"/>
   <p:embeddedFontLst>
     <p:embeddedFont>
-      <p:font typeface="Dancing Script" panose="020B0604020202020204" charset="0"/>
-      <p:regular r:id="rId4"/>
-      <p:bold r:id="rId5"/>
+      <p:font typeface="Amasis MT Pro Black" panose="02040A04050005020304" pitchFamily="18" charset="0"/>
+      <p:bold r:id="rId4"/>
     </p:embeddedFont>
     <p:embeddedFont>
-      <p:font typeface="Georgia" panose="02040502050405020303" pitchFamily="18" charset="0"/>
-      <p:regular r:id="rId6"/>
-      <p:bold r:id="rId7"/>
-      <p:italic r:id="rId8"/>
-      <p:boldItalic r:id="rId9"/>
+      <p:font typeface="Candara Light" panose="020E0502030303020204" pitchFamily="34" charset="0"/>
+      <p:regular r:id="rId5"/>
+      <p:italic r:id="rId6"/>
+    </p:embeddedFont>
+    <p:embeddedFont>
+      <p:font typeface="Dancing Script" panose="020B0604020202020204" charset="0"/>
+      <p:regular r:id="rId7"/>
+      <p:bold r:id="rId8"/>
     </p:embeddedFont>
     <p:embeddedFont>
       <p:font typeface="Great Vibes" panose="020B0604020202020204" charset="-52"/>
-      <p:regular r:id="rId10"/>
+      <p:regular r:id="rId9"/>
     </p:embeddedFont>
   </p:embeddedFontLst>
   <p:defaultTextStyle>
@@ -5380,7 +5382,7 @@
         </p:nvSpPr>
         <p:spPr>
           <a:xfrm>
-            <a:off x="2941200" y="1272500"/>
+            <a:off x="2882253" y="1354665"/>
             <a:ext cx="3261600" cy="792600"/>
           </a:xfrm>
           <a:prstGeom prst="rect">
@@ -5404,7 +5406,7 @@
               <a:buNone/>
             </a:pPr>
             <a:r>
-              <a:rPr lang="uz" sz="4880">
+              <a:rPr lang="uz" sz="4880" dirty="0">
                 <a:solidFill>
                   <a:srgbClr val="6D9EEB"/>
                 </a:solidFill>
@@ -5415,7 +5417,7 @@
               </a:rPr>
               <a:t>Sertifikat</a:t>
             </a:r>
-            <a:endParaRPr sz="4880">
+            <a:endParaRPr sz="4880" dirty="0">
               <a:solidFill>
                 <a:srgbClr val="6D9EEB"/>
               </a:solidFill>
@@ -5439,8 +5441,8 @@
         </p:nvSpPr>
         <p:spPr>
           <a:xfrm>
-            <a:off x="1237325" y="2761750"/>
-            <a:ext cx="6759900" cy="435300"/>
+            <a:off x="1237325" y="2761749"/>
+            <a:ext cx="6759900" cy="604813"/>
           </a:xfrm>
           <a:prstGeom prst="rect">
             <a:avLst/>
@@ -5452,40 +5454,12 @@
           </a:bodyPr>
           <a:lstStyle/>
           <a:p>
-            <a:pPr marL="0" lvl="0" indent="0" algn="ctr" rtl="0">
-              <a:lnSpc>
-                <a:spcPct val="80000"/>
-              </a:lnSpc>
-              <a:spcBef>
-                <a:spcPts val="0"/>
-              </a:spcBef>
-              <a:spcAft>
-                <a:spcPts val="0"/>
-              </a:spcAft>
-              <a:buSzPts val="770"/>
-              <a:buNone/>
-            </a:pPr>
             <a:r>
-              <a:rPr lang="uz" sz="1260">
-                <a:solidFill>
-                  <a:srgbClr val="1C4587"/>
-                </a:solidFill>
-                <a:latin typeface="Georgia"/>
-                <a:ea typeface="Georgia"/>
-                <a:cs typeface="Georgia"/>
-                <a:sym typeface="Georgia"/>
+              <a:rPr lang="uz-Latn-UZ" sz="1000" b="1" cap="all" dirty="0">
+                <a:latin typeface="Amasis MT Pro Black" panose="02040A04050005020304" pitchFamily="18" charset="0"/>
               </a:rPr>
-              <a:t>{{mavzu}}</a:t>
+              <a:t>Boshlang‘ich sinflarda o‘simliklar anatomiyasi, fiziologiyasi, sistematikasi va shakllarini o‘qitishning pedagogik-metodik tizimi</a:t>
             </a:r>
-            <a:endParaRPr sz="1260">
-              <a:solidFill>
-                <a:srgbClr val="1C4587"/>
-              </a:solidFill>
-              <a:latin typeface="Georgia"/>
-              <a:ea typeface="Georgia"/>
-              <a:cs typeface="Georgia"/>
-              <a:sym typeface="Georgia"/>
-            </a:endParaRPr>
           </a:p>
         </p:txBody>
       </p:sp>
@@ -5601,56 +5575,6 @@
           </a:ln>
         </p:spPr>
       </p:pic>
-      <p:sp>
-        <p:nvSpPr>
-          <p:cNvPr id="60" name="Google Shape;60;p13"/>
-          <p:cNvSpPr txBox="1"/>
-          <p:nvPr/>
-        </p:nvSpPr>
-        <p:spPr>
-          <a:xfrm>
-            <a:off x="1565075" y="4099825"/>
-            <a:ext cx="821700" cy="693000"/>
-          </a:xfrm>
-          <a:prstGeom prst="rect">
-            <a:avLst/>
-          </a:prstGeom>
-          <a:noFill/>
-          <a:ln>
-            <a:noFill/>
-          </a:ln>
-        </p:spPr>
-        <p:txBody>
-          <a:bodyPr spcFirstLastPara="1" wrap="square" lIns="91425" tIns="91425" rIns="91425" bIns="91425" anchor="t" anchorCtr="0">
-            <a:noAutofit/>
-          </a:bodyPr>
-          <a:lstStyle/>
-          <a:p>
-            <a:pPr marL="0" lvl="0" indent="0" algn="l" rtl="0">
-              <a:spcBef>
-                <a:spcPts val="0"/>
-              </a:spcBef>
-              <a:spcAft>
-                <a:spcPts val="0"/>
-              </a:spcAft>
-              <a:buNone/>
-            </a:pPr>
-            <a:r>
-              <a:rPr lang="uz" sz="1800">
-                <a:solidFill>
-                  <a:schemeClr val="dk2"/>
-                </a:solidFill>
-              </a:rPr>
-              <a:t>{{qr}}</a:t>
-            </a:r>
-            <a:endParaRPr sz="1800">
-              <a:solidFill>
-                <a:schemeClr val="dk2"/>
-              </a:solidFill>
-            </a:endParaRPr>
-          </a:p>
-        </p:txBody>
-      </p:sp>
       <p:cxnSp>
         <p:nvCxnSpPr>
           <p:cNvPr id="61" name="Google Shape;61;p13"/>
@@ -5702,27 +5626,18 @@
           </a:bodyPr>
           <a:lstStyle/>
           <a:p>
-            <a:pPr marL="0" lvl="0" indent="0" algn="ctr" rtl="0">
-              <a:spcBef>
-                <a:spcPts val="0"/>
-              </a:spcBef>
-              <a:spcAft>
-                <a:spcPts val="0"/>
-              </a:spcAft>
-              <a:buNone/>
-            </a:pPr>
+            <a:pPr lvl="0" algn="ctr"/>
             <a:r>
-              <a:rPr lang="uz" sz="1700">
-                <a:solidFill>
-                  <a:schemeClr val="dk2"/>
-                </a:solidFill>
+              <a:rPr lang="uz-Latn-UZ" b="1" dirty="0">
+                <a:latin typeface="Candara Light" panose="020E0502030303020204" pitchFamily="34" charset="0"/>
               </a:rPr>
-              <a:t>{{ism_familya}}</a:t>
+              <a:t>Usmonova Xurshida Aybekovna , Abdulhayeva Xabibaxon</a:t>
             </a:r>
-            <a:endParaRPr sz="1700">
+            <a:endParaRPr sz="1700" dirty="0">
               <a:solidFill>
                 <a:schemeClr val="dk2"/>
               </a:solidFill>
+              <a:latin typeface="Candara Light" panose="020E0502030303020204" pitchFamily="34" charset="0"/>
             </a:endParaRPr>
           </a:p>
         </p:txBody>
@@ -5762,14 +5677,14 @@
               <a:buNone/>
             </a:pPr>
             <a:r>
-              <a:rPr lang="uz" sz="800">
+              <a:rPr lang="uz" sz="800" dirty="0">
                 <a:solidFill>
                   <a:srgbClr val="20124D"/>
                 </a:solidFill>
               </a:rPr>
-              <a:t>Sana / Date: {{sana}} </a:t>
+              <a:t>Sana / Date: 07.06.2026 </a:t>
             </a:r>
-            <a:endParaRPr sz="600">
+            <a:endParaRPr sz="600" dirty="0">
               <a:solidFill>
                 <a:srgbClr val="20124D"/>
               </a:solidFill>
@@ -5785,8 +5700,8 @@
         </p:nvSpPr>
         <p:spPr>
           <a:xfrm>
-            <a:off x="1090700" y="1168050"/>
-            <a:ext cx="2418900" cy="292500"/>
+            <a:off x="982859" y="1214964"/>
+            <a:ext cx="2418900" cy="307746"/>
           </a:xfrm>
           <a:prstGeom prst="rect">
             <a:avLst/>
@@ -5802,24 +5717,16 @@
           </a:bodyPr>
           <a:lstStyle/>
           <a:p>
-            <a:pPr marL="0" lvl="0" indent="0" algn="l" rtl="0">
-              <a:spcBef>
-                <a:spcPts val="0"/>
-              </a:spcBef>
-              <a:spcAft>
-                <a:spcPts val="0"/>
-              </a:spcAft>
-              <a:buNone/>
-            </a:pPr>
+            <a:pPr lvl="0"/>
             <a:r>
-              <a:rPr lang="uz" sz="700">
-                <a:solidFill>
-                  <a:srgbClr val="20124D"/>
-                </a:solidFill>
-              </a:rPr>
-              <a:t>DOI: 10.36001/tamaddun.{{yil}}.{{jild}}.{{nashr}}.xxxxxxx</a:t>
+              <a:rPr lang="pt-BR" sz="800" b="1" dirty="0"/>
+              <a:t>DOI:</a:t>
             </a:r>
-            <a:endParaRPr sz="700">
+            <a:r>
+              <a:rPr lang="pt-BR" sz="800" dirty="0"/>
+              <a:t> 10.36001/tamaddun.2026.3.4.a2e6c772</a:t>
+            </a:r>
+            <a:endParaRPr sz="100" dirty="0">
               <a:solidFill>
                 <a:srgbClr val="20124D"/>
               </a:solidFill>
@@ -5920,7 +5827,7 @@
               <a:buNone/>
             </a:pPr>
             <a:r>
-              <a:rPr lang="uz" sz="1000" b="1">
+              <a:rPr lang="uz" sz="1000" b="1" dirty="0">
                 <a:solidFill>
                   <a:srgbClr val="1C4587"/>
                 </a:solidFill>
@@ -5929,9 +5836,9 @@
                 <a:cs typeface="Dancing Script"/>
                 <a:sym typeface="Dancing Script"/>
               </a:rPr>
-              <a:t>«Tamaddun» ilmiy jurnalining Jild {{jild}}, Nashr {{nashr}} ({{yil}}) sonida chop etildi.</a:t>
+              <a:t>«Tamaddun» ilmiy jurnalining Jild 1, Nashr 3;  6 sonida chop etildi.</a:t>
             </a:r>
-            <a:endParaRPr sz="1000" b="1">
+            <a:endParaRPr sz="1000" b="1" dirty="0">
               <a:solidFill>
                 <a:srgbClr val="1C4587"/>
               </a:solidFill>
@@ -6073,6 +5980,36 @@
           <a:xfrm>
             <a:off x="6151679" y="4246490"/>
             <a:ext cx="865118" cy="293038"/>
+          </a:xfrm>
+          <a:prstGeom prst="rect">
+            <a:avLst/>
+          </a:prstGeom>
+        </p:spPr>
+      </p:pic>
+      <p:pic>
+        <p:nvPicPr>
+          <p:cNvPr id="3" name="Рисунок 2">
+            <a:extLst>
+              <a:ext uri="{FF2B5EF4-FFF2-40B4-BE49-F238E27FC236}">
+                <a16:creationId xmlns:a16="http://schemas.microsoft.com/office/drawing/2014/main" id="{CE00F69F-9885-164F-73B9-4CBB3CC656E6}"/>
+              </a:ext>
+            </a:extLst>
+          </p:cNvPr>
+          <p:cNvPicPr>
+            <a:picLocks noChangeAspect="1"/>
+          </p:cNvPicPr>
+          <p:nvPr/>
+        </p:nvPicPr>
+        <p:blipFill>
+          <a:blip r:embed="rId10"/>
+          <a:stretch>
+            <a:fillRect/>
+          </a:stretch>
+        </p:blipFill>
+        <p:spPr>
+          <a:xfrm>
+            <a:off x="1533869" y="4128266"/>
+            <a:ext cx="593334" cy="593334"/>
           </a:xfrm>
           <a:prstGeom prst="rect">
             <a:avLst/>

</xml_diff>